<commit_message>
added pawtograder, updated based on feedback
</commit_message>
<xml_diff>
--- a/Slides/Module 01.1 Course Introduction.pptx
+++ b/Slides/Module 01.1 Course Introduction.pptx
@@ -3196,7 +3196,7 @@
           <a:p>
             <a:fld id="{7C7E5181-6CF5-45F7-A87A-E0E0B1FD7549}" type="datetimeFigureOut">
               <a:rPr lang="en-US" smtClean="0"/>
-              <a:t>7/8/2026</a:t>
+              <a:t>8/17/2026</a:t>
             </a:fld>
             <a:endParaRPr lang="en-US"/>
           </a:p>
@@ -6055,7 +6055,7 @@
           <a:p>
             <a:fld id="{5D2A64DE-480B-420F-9649-4F8E696E08E0}" type="datetime1">
               <a:rPr lang="en-US" smtClean="0"/>
-              <a:t>7/8/2026</a:t>
+              <a:t>8/17/2026</a:t>
             </a:fld>
             <a:endParaRPr lang="en-US"/>
           </a:p>
@@ -6289,7 +6289,7 @@
           <a:p>
             <a:fld id="{0D3616D0-8311-4107-9726-6B805E7D05BA}" type="datetime1">
               <a:rPr lang="en-US" smtClean="0"/>
-              <a:t>7/8/2026</a:t>
+              <a:t>8/17/2026</a:t>
             </a:fld>
             <a:endParaRPr lang="en-US"/>
           </a:p>
@@ -6497,7 +6497,7 @@
           <a:p>
             <a:fld id="{3BC2557A-5C88-417A-A763-5AC779462A5F}" type="datetime1">
               <a:rPr lang="en-US" smtClean="0"/>
-              <a:t>7/8/2026</a:t>
+              <a:t>8/17/2026</a:t>
             </a:fld>
             <a:endParaRPr lang="en-US"/>
           </a:p>
@@ -7021,7 +7021,7 @@
           <a:p>
             <a:fld id="{07C7BFD4-467E-4EDE-93EA-052F5B39A4E5}" type="datetime1">
               <a:rPr lang="en-US" smtClean="0"/>
-              <a:t>7/8/2026</a:t>
+              <a:t>8/17/2026</a:t>
             </a:fld>
             <a:endParaRPr lang="en-US"/>
           </a:p>
@@ -7334,7 +7334,7 @@
           <a:p>
             <a:fld id="{A533CBE2-D5BE-47AC-ADC2-9CDFC1D0CF90}" type="datetime1">
               <a:rPr lang="en-US" smtClean="0"/>
-              <a:t>7/8/2026</a:t>
+              <a:t>8/17/2026</a:t>
             </a:fld>
             <a:endParaRPr lang="en-US"/>
           </a:p>
@@ -7635,7 +7635,7 @@
           <a:p>
             <a:fld id="{39B7EDB1-CE74-4951-85A2-0B01C2128E28}" type="datetime1">
               <a:rPr lang="en-US" smtClean="0"/>
-              <a:t>7/8/2026</a:t>
+              <a:t>8/17/2026</a:t>
             </a:fld>
             <a:endParaRPr lang="en-US"/>
           </a:p>
@@ -8083,7 +8083,7 @@
           <a:p>
             <a:fld id="{2BC7EB92-A5C2-4807-A9DC-9EDE6CBFB241}" type="datetime1">
               <a:rPr lang="en-US" smtClean="0"/>
-              <a:t>7/8/2026</a:t>
+              <a:t>8/17/2026</a:t>
             </a:fld>
             <a:endParaRPr lang="en-US"/>
           </a:p>
@@ -8229,7 +8229,7 @@
           <a:p>
             <a:fld id="{109E55A0-C911-4F03-82FC-7E5926047D46}" type="datetime1">
               <a:rPr lang="en-US" smtClean="0"/>
-              <a:t>7/8/2026</a:t>
+              <a:t>8/17/2026</a:t>
             </a:fld>
             <a:endParaRPr lang="en-US"/>
           </a:p>
@@ -8378,7 +8378,7 @@
           <a:p>
             <a:fld id="{2B7B7EE0-7771-4CD5-9B2B-3550753A54A1}" type="datetime1">
               <a:rPr lang="en-US" smtClean="0"/>
-              <a:t>7/8/2026</a:t>
+              <a:t>8/17/2026</a:t>
             </a:fld>
             <a:endParaRPr lang="en-US"/>
           </a:p>
@@ -8689,7 +8689,7 @@
           <a:p>
             <a:fld id="{F8B318B3-0E87-4416-A9B8-D891968C2727}" type="datetime1">
               <a:rPr lang="en-US" smtClean="0"/>
-              <a:t>7/8/2026</a:t>
+              <a:t>8/17/2026</a:t>
             </a:fld>
             <a:endParaRPr lang="en-US"/>
           </a:p>
@@ -8977,7 +8977,7 @@
           <a:p>
             <a:fld id="{EA476A42-A091-4468-A075-64A31BE59948}" type="datetime1">
               <a:rPr lang="en-US" smtClean="0"/>
-              <a:t>7/8/2026</a:t>
+              <a:t>8/17/2026</a:t>
             </a:fld>
             <a:endParaRPr lang="en-US"/>
           </a:p>
@@ -9218,7 +9218,7 @@
           <a:p>
             <a:fld id="{54D997E8-DDEE-43F1-8D9B-F8A1E11DE488}" type="datetime1">
               <a:rPr lang="en-US" smtClean="0"/>
-              <a:t>7/8/2026</a:t>
+              <a:t>8/17/2026</a:t>
             </a:fld>
             <a:endParaRPr lang="en-US"/>
           </a:p>
@@ -14997,11 +14997,19 @@
             <a:pPr lvl="1"/>
             <a:r>
               <a:rPr lang="en-US" dirty="0"/>
-              <a:t>these will be</a:t>
+              <a:t>these will be </a:t>
             </a:r>
             <a:r>
               <a:rPr lang="en-US" b="1" dirty="0"/>
-              <a:t> graded. </a:t>
+              <a:t>submitted </a:t>
+            </a:r>
+            <a:r>
+              <a:rPr lang="en-US" dirty="0"/>
+              <a:t>on Canvas and</a:t>
+            </a:r>
+            <a:r>
+              <a:rPr lang="en-US" b="1" dirty="0"/>
+              <a:t> graded</a:t>
             </a:r>
           </a:p>
           <a:p>
@@ -15313,14 +15321,7 @@
             <a:pPr lvl="1"/>
             <a:r>
               <a:rPr lang="en-US" dirty="0"/>
-              <a:t>divided into 3 deliverable projects</a:t>
-            </a:r>
-          </a:p>
-          <a:p>
-            <a:pPr lvl="1"/>
-            <a:r>
-              <a:rPr lang="en-US" dirty="0"/>
-              <a:t>this counts for 30% of course grade</a:t>
+              <a:t>divided into 3 deliverable projects, counts for 30% of course grade</a:t>
             </a:r>
             <a:endParaRPr lang="en-US" b="1" dirty="0"/>
           </a:p>
@@ -15363,6 +15364,22 @@
             <a:r>
               <a:rPr lang="en-US" dirty="0"/>
               <a:t>this counts for 40% of course grade</a:t>
+            </a:r>
+          </a:p>
+          <a:p>
+            <a:r>
+              <a:rPr lang="en-US" dirty="0"/>
+              <a:t>We use </a:t>
+            </a:r>
+            <a:r>
+              <a:rPr lang="en-US" dirty="0" err="1">
+                <a:hlinkClick r:id="rId3"/>
+              </a:rPr>
+              <a:t>pawtograder</a:t>
+            </a:r>
+            <a:r>
+              <a:rPr lang="en-US" dirty="0"/>
+              <a:t> managing project repos</a:t>
             </a:r>
           </a:p>
           <a:p>
@@ -17378,15 +17395,7 @@
             <a:pPr lvl="1"/>
             <a:r>
               <a:rPr lang="en-US" dirty="0"/>
-              <a:t>We provide mechanism for you to request regrades for all work submitted (usually </a:t>
-            </a:r>
-            <a:r>
-              <a:rPr lang="en-US" dirty="0" err="1"/>
-              <a:t>Gradescope</a:t>
-            </a:r>
-            <a:r>
-              <a:rPr lang="en-US" dirty="0"/>
-              <a:t> appeals)</a:t>
+              <a:t>We provide mechanism for you to request regrades for all work submitted</a:t>
             </a:r>
           </a:p>
           <a:p>
@@ -19177,7 +19186,7 @@
         </p:spPr>
         <p:txBody>
           <a:bodyPr>
-            <a:normAutofit fontScale="92500" lnSpcReduction="20000"/>
+            <a:normAutofit fontScale="92500" lnSpcReduction="10000"/>
           </a:bodyPr>
           <a:lstStyle/>
           <a:p>
@@ -19261,13 +19270,6 @@
             <a:r>
               <a:rPr lang="en-US" dirty="0"/>
               <a:t>so your message does not get overlooked</a:t>
-            </a:r>
-          </a:p>
-          <a:p>
-            <a:pPr lvl="1"/>
-            <a:r>
-              <a:rPr lang="en-US" dirty="0"/>
-              <a:t>We encourage all students to “meet” with the instructor at least once! </a:t>
             </a:r>
           </a:p>
           <a:p>

</xml_diff>

<commit_message>
minor edits on 1.1 and 1.2
</commit_message>
<xml_diff>
--- a/Slides/Module 01.1 Course Introduction.pptx
+++ b/Slides/Module 01.1 Course Introduction.pptx
@@ -3196,7 +3196,7 @@
           <a:p>
             <a:fld id="{7C7E5181-6CF5-45F7-A87A-E0E0B1FD7549}" type="datetimeFigureOut">
               <a:rPr lang="en-US" smtClean="0"/>
-              <a:t>8/17/2026</a:t>
+              <a:t>8/18/2026</a:t>
             </a:fld>
             <a:endParaRPr lang="en-US"/>
           </a:p>
@@ -6055,7 +6055,7 @@
           <a:p>
             <a:fld id="{5D2A64DE-480B-420F-9649-4F8E696E08E0}" type="datetime1">
               <a:rPr lang="en-US" smtClean="0"/>
-              <a:t>8/17/2026</a:t>
+              <a:t>8/18/2026</a:t>
             </a:fld>
             <a:endParaRPr lang="en-US"/>
           </a:p>
@@ -6289,7 +6289,7 @@
           <a:p>
             <a:fld id="{0D3616D0-8311-4107-9726-6B805E7D05BA}" type="datetime1">
               <a:rPr lang="en-US" smtClean="0"/>
-              <a:t>8/17/2026</a:t>
+              <a:t>8/18/2026</a:t>
             </a:fld>
             <a:endParaRPr lang="en-US"/>
           </a:p>
@@ -6497,7 +6497,7 @@
           <a:p>
             <a:fld id="{3BC2557A-5C88-417A-A763-5AC779462A5F}" type="datetime1">
               <a:rPr lang="en-US" smtClean="0"/>
-              <a:t>8/17/2026</a:t>
+              <a:t>8/18/2026</a:t>
             </a:fld>
             <a:endParaRPr lang="en-US"/>
           </a:p>
@@ -7021,7 +7021,7 @@
           <a:p>
             <a:fld id="{07C7BFD4-467E-4EDE-93EA-052F5B39A4E5}" type="datetime1">
               <a:rPr lang="en-US" smtClean="0"/>
-              <a:t>8/17/2026</a:t>
+              <a:t>8/18/2026</a:t>
             </a:fld>
             <a:endParaRPr lang="en-US"/>
           </a:p>
@@ -7334,7 +7334,7 @@
           <a:p>
             <a:fld id="{A533CBE2-D5BE-47AC-ADC2-9CDFC1D0CF90}" type="datetime1">
               <a:rPr lang="en-US" smtClean="0"/>
-              <a:t>8/17/2026</a:t>
+              <a:t>8/18/2026</a:t>
             </a:fld>
             <a:endParaRPr lang="en-US"/>
           </a:p>
@@ -7635,7 +7635,7 @@
           <a:p>
             <a:fld id="{39B7EDB1-CE74-4951-85A2-0B01C2128E28}" type="datetime1">
               <a:rPr lang="en-US" smtClean="0"/>
-              <a:t>8/17/2026</a:t>
+              <a:t>8/18/2026</a:t>
             </a:fld>
             <a:endParaRPr lang="en-US"/>
           </a:p>
@@ -8083,7 +8083,7 @@
           <a:p>
             <a:fld id="{2BC7EB92-A5C2-4807-A9DC-9EDE6CBFB241}" type="datetime1">
               <a:rPr lang="en-US" smtClean="0"/>
-              <a:t>8/17/2026</a:t>
+              <a:t>8/18/2026</a:t>
             </a:fld>
             <a:endParaRPr lang="en-US"/>
           </a:p>
@@ -8229,7 +8229,7 @@
           <a:p>
             <a:fld id="{109E55A0-C911-4F03-82FC-7E5926047D46}" type="datetime1">
               <a:rPr lang="en-US" smtClean="0"/>
-              <a:t>8/17/2026</a:t>
+              <a:t>8/18/2026</a:t>
             </a:fld>
             <a:endParaRPr lang="en-US"/>
           </a:p>
@@ -8378,7 +8378,7 @@
           <a:p>
             <a:fld id="{2B7B7EE0-7771-4CD5-9B2B-3550753A54A1}" type="datetime1">
               <a:rPr lang="en-US" smtClean="0"/>
-              <a:t>8/17/2026</a:t>
+              <a:t>8/18/2026</a:t>
             </a:fld>
             <a:endParaRPr lang="en-US"/>
           </a:p>
@@ -8689,7 +8689,7 @@
           <a:p>
             <a:fld id="{F8B318B3-0E87-4416-A9B8-D891968C2727}" type="datetime1">
               <a:rPr lang="en-US" smtClean="0"/>
-              <a:t>8/17/2026</a:t>
+              <a:t>8/18/2026</a:t>
             </a:fld>
             <a:endParaRPr lang="en-US"/>
           </a:p>
@@ -8977,7 +8977,7 @@
           <a:p>
             <a:fld id="{EA476A42-A091-4468-A075-64A31BE59948}" type="datetime1">
               <a:rPr lang="en-US" smtClean="0"/>
-              <a:t>8/17/2026</a:t>
+              <a:t>8/18/2026</a:t>
             </a:fld>
             <a:endParaRPr lang="en-US"/>
           </a:p>
@@ -9218,7 +9218,7 @@
           <a:p>
             <a:fld id="{54D997E8-DDEE-43F1-8D9B-F8A1E11DE488}" type="datetime1">
               <a:rPr lang="en-US" smtClean="0"/>
-              <a:t>8/17/2026</a:t>
+              <a:t>8/18/2026</a:t>
             </a:fld>
             <a:endParaRPr lang="en-US"/>
           </a:p>
@@ -15310,18 +15310,27 @@
             </a:r>
             <a:r>
               <a:rPr lang="en-US" b="1" dirty="0"/>
-              <a:t>individually</a:t>
+              <a:t>individually.</a:t>
             </a:r>
             <a:r>
               <a:rPr lang="en-US" dirty="0"/>
-              <a:t>. </a:t>
-            </a:r>
-          </a:p>
-          <a:p>
-            <a:pPr lvl="1"/>
+              <a:t> It is </a:t>
+            </a:r>
+            <a:r>
+              <a:rPr lang="en-US" dirty="0" err="1"/>
+              <a:t>devided</a:t>
+            </a:r>
             <a:r>
               <a:rPr lang="en-US" dirty="0"/>
-              <a:t>divided into 3 deliverable projects, counts for 30% of course grade</a:t>
+              <a:t> into 3 deliverable stages.  Together these count for </a:t>
+            </a:r>
+            <a:r>
+              <a:rPr lang="en-US" b="1" dirty="0"/>
+              <a:t>30% </a:t>
+            </a:r>
+            <a:r>
+              <a:rPr lang="en-US" dirty="0"/>
+              <a:t>of the course grade.</a:t>
             </a:r>
             <a:endParaRPr lang="en-US" b="1" dirty="0"/>
           </a:p>
@@ -15356,30 +15365,15 @@
             </a:r>
             <a:r>
               <a:rPr lang="en-US" dirty="0"/>
-              <a:t> people </a:t>
-            </a:r>
-          </a:p>
-          <a:p>
-            <a:pPr lvl="1"/>
+              <a:t> people. This counts for </a:t>
+            </a:r>
+            <a:r>
+              <a:rPr lang="en-US" b="1" dirty="0"/>
+              <a:t>40% </a:t>
+            </a:r>
             <a:r>
               <a:rPr lang="en-US" dirty="0"/>
-              <a:t>this counts for 40% of course grade</a:t>
-            </a:r>
-          </a:p>
-          <a:p>
-            <a:r>
-              <a:rPr lang="en-US" dirty="0"/>
-              <a:t>We use </a:t>
-            </a:r>
-            <a:r>
-              <a:rPr lang="en-US" dirty="0" err="1">
-                <a:hlinkClick r:id="rId3"/>
-              </a:rPr>
-              <a:t>pawtograder</a:t>
-            </a:r>
-            <a:r>
-              <a:rPr lang="en-US" dirty="0"/>
-              <a:t> managing project repos</a:t>
+              <a:t>of the course grade</a:t>
             </a:r>
           </a:p>
           <a:p>
@@ -15393,11 +15387,23 @@
                   <a:srgbClr val="FF0000"/>
                 </a:solidFill>
               </a:rPr>
-              <a:t>Week 9 (Nov 4-6</a:t>
+              <a:t>Week 9 (Nov 4-6)</a:t>
             </a:r>
             <a:r>
               <a:rPr lang="en-US" dirty="0"/>
-              <a:t>). There will not be a final exam. </a:t>
+              <a:t>.</a:t>
+            </a:r>
+            <a:r>
+              <a:rPr lang="en-US" dirty="0">
+                <a:solidFill>
+                  <a:srgbClr val="FF0000"/>
+                </a:solidFill>
+              </a:rPr>
+              <a:t> </a:t>
+            </a:r>
+            <a:r>
+              <a:rPr lang="en-US" dirty="0"/>
+              <a:t>There will not be a final exam. </a:t>
             </a:r>
             <a:r>
               <a:rPr lang="en-US" u="sng" dirty="0"/>
@@ -15407,7 +15413,7 @@
           <a:p>
             <a:r>
               <a:rPr lang="en-US" dirty="0"/>
-              <a:t>Participation / Completion of activities (10%)</a:t>
+              <a:t>Completion of activities (worth 10%)</a:t>
             </a:r>
           </a:p>
         </p:txBody>
@@ -15757,6 +15763,19 @@
             <a:r>
               <a:rPr lang="en-US" dirty="0"/>
               <a:t>GitHub Actions / Render for CI/CD</a:t>
+            </a:r>
+          </a:p>
+          <a:p>
+            <a:pPr lvl="1"/>
+            <a:r>
+              <a:rPr lang="en-US" dirty="0" err="1">
+                <a:hlinkClick r:id="rId2"/>
+              </a:rPr>
+              <a:t>Pawtograder</a:t>
+            </a:r>
+            <a:r>
+              <a:rPr lang="en-US" dirty="0"/>
+              <a:t> as our LMS (grading, submission, etc.)</a:t>
             </a:r>
           </a:p>
           <a:p>
@@ -16970,7 +16989,7 @@
           <a:p>
             <a:r>
               <a:rPr lang="en-US" dirty="0"/>
-              <a:t>The team project (worth 40%) will be a new feature that you will propose.</a:t>
+              <a:t>The team project (worth 40% of the course grade) will be a new feature that you will propose.</a:t>
             </a:r>
           </a:p>
           <a:p>
@@ -21538,16 +21557,16 @@
           <a:lstStyle/>
           <a:p>
             <a:r>
-              <a:rPr lang="en-US">
+              <a:rPr lang="en-US" dirty="0">
                 <a:solidFill>
                   <a:schemeClr val="bg1"/>
                 </a:solidFill>
                 <a:latin typeface="Verdana"/>
                 <a:ea typeface="Verdana"/>
               </a:rPr>
-              <a:t>Okay, what do you mean by "large"</a:t>
-            </a:r>
-            <a:endParaRPr lang="en-US">
+              <a:t>Okay, what do you mean by "large"?</a:t>
+            </a:r>
+            <a:endParaRPr lang="en-US" dirty="0">
               <a:solidFill>
                 <a:schemeClr val="bg1"/>
               </a:solidFill>

</xml_diff>

<commit_message>
last pass and fixed typos
</commit_message>
<xml_diff>
--- a/Slides/Module 01.1 Course Introduction.pptx
+++ b/Slides/Module 01.1 Course Introduction.pptx
@@ -153,7 +153,7 @@
 </file>
 
 <file path=ppt/diagrams/colors1.xml><?xml version="1.0" encoding="utf-8"?>
-<dgm:colorsDef xmlns:dgm="http://schemas.openxmlformats.org/drawingml/2006/diagram" xmlns:a="http://schemas.openxmlformats.org/drawingml/2006/main" uniqueId="urn:microsoft.com/office/officeart/2005/8/colors/colorful5">
+<dgm:colorsDef xmlns:dgm="http://schemas.openxmlformats.org/drawingml/2006/diagram" xmlns:a="http://schemas.openxmlformats.org/drawingml/2006/main" uniqueId="urn:microsoft.com/office/officeart/2005/8/colors/colorful5#1">
   <dgm:title val=""/>
   <dgm:desc val=""/>
   <dgm:catLst>
@@ -938,7 +938,7 @@
 <dgm:dataModel xmlns:dgm="http://schemas.openxmlformats.org/drawingml/2006/diagram" xmlns:a="http://schemas.openxmlformats.org/drawingml/2006/main">
   <dgm:ptLst>
     <dgm:pt modelId="{DDBF1F72-D5C6-45C1-8861-C60BF5F24714}" type="doc">
-      <dgm:prSet loTypeId="urn:microsoft.com/office/officeart/2005/8/layout/list1" loCatId="list" qsTypeId="urn:microsoft.com/office/officeart/2005/8/quickstyle/simple4" qsCatId="simple" csTypeId="urn:microsoft.com/office/officeart/2005/8/colors/colorful5" csCatId="colorful" phldr="1"/>
+      <dgm:prSet loTypeId="urn:microsoft.com/office/officeart/2005/8/layout/list1" loCatId="list" qsTypeId="urn:microsoft.com/office/officeart/2005/8/quickstyle/simple4#1" qsCatId="simple" csTypeId="urn:microsoft.com/office/officeart/2005/8/colors/colorful5#1" csCatId="colorful" phldr="1"/>
       <dgm:spPr/>
       <dgm:t>
         <a:bodyPr/>
@@ -2081,7 +2081,7 @@
 </file>
 
 <file path=ppt/diagrams/quickStyle1.xml><?xml version="1.0" encoding="utf-8"?>
-<dgm:styleDef xmlns:dgm="http://schemas.openxmlformats.org/drawingml/2006/diagram" xmlns:a="http://schemas.openxmlformats.org/drawingml/2006/main" uniqueId="urn:microsoft.com/office/officeart/2005/8/quickstyle/simple4">
+<dgm:styleDef xmlns:dgm="http://schemas.openxmlformats.org/drawingml/2006/diagram" xmlns:a="http://schemas.openxmlformats.org/drawingml/2006/main" uniqueId="urn:microsoft.com/office/officeart/2005/8/quickstyle/simple4#1">
   <dgm:title val=""/>
   <dgm:desc val=""/>
   <dgm:catLst>
@@ -3196,7 +3196,7 @@
           <a:p>
             <a:fld id="{7C7E5181-6CF5-45F7-A87A-E0E0B1FD7549}" type="datetimeFigureOut">
               <a:rPr lang="en-US" smtClean="0"/>
-              <a:t>8/18/2026</a:t>
+              <a:t>8/20/2026</a:t>
             </a:fld>
             <a:endParaRPr lang="en-US"/>
           </a:p>
@@ -6055,7 +6055,7 @@
           <a:p>
             <a:fld id="{5D2A64DE-480B-420F-9649-4F8E696E08E0}" type="datetime1">
               <a:rPr lang="en-US" smtClean="0"/>
-              <a:t>8/18/2026</a:t>
+              <a:t>8/20/2026</a:t>
             </a:fld>
             <a:endParaRPr lang="en-US"/>
           </a:p>
@@ -6289,7 +6289,7 @@
           <a:p>
             <a:fld id="{0D3616D0-8311-4107-9726-6B805E7D05BA}" type="datetime1">
               <a:rPr lang="en-US" smtClean="0"/>
-              <a:t>8/18/2026</a:t>
+              <a:t>8/20/2026</a:t>
             </a:fld>
             <a:endParaRPr lang="en-US"/>
           </a:p>
@@ -6497,7 +6497,7 @@
           <a:p>
             <a:fld id="{3BC2557A-5C88-417A-A763-5AC779462A5F}" type="datetime1">
               <a:rPr lang="en-US" smtClean="0"/>
-              <a:t>8/18/2026</a:t>
+              <a:t>8/20/2026</a:t>
             </a:fld>
             <a:endParaRPr lang="en-US"/>
           </a:p>
@@ -7021,7 +7021,7 @@
           <a:p>
             <a:fld id="{07C7BFD4-467E-4EDE-93EA-052F5B39A4E5}" type="datetime1">
               <a:rPr lang="en-US" smtClean="0"/>
-              <a:t>8/18/2026</a:t>
+              <a:t>8/20/2026</a:t>
             </a:fld>
             <a:endParaRPr lang="en-US"/>
           </a:p>
@@ -7334,7 +7334,7 @@
           <a:p>
             <a:fld id="{A533CBE2-D5BE-47AC-ADC2-9CDFC1D0CF90}" type="datetime1">
               <a:rPr lang="en-US" smtClean="0"/>
-              <a:t>8/18/2026</a:t>
+              <a:t>8/20/2026</a:t>
             </a:fld>
             <a:endParaRPr lang="en-US"/>
           </a:p>
@@ -7635,7 +7635,7 @@
           <a:p>
             <a:fld id="{39B7EDB1-CE74-4951-85A2-0B01C2128E28}" type="datetime1">
               <a:rPr lang="en-US" smtClean="0"/>
-              <a:t>8/18/2026</a:t>
+              <a:t>8/20/2026</a:t>
             </a:fld>
             <a:endParaRPr lang="en-US"/>
           </a:p>
@@ -8083,7 +8083,7 @@
           <a:p>
             <a:fld id="{2BC7EB92-A5C2-4807-A9DC-9EDE6CBFB241}" type="datetime1">
               <a:rPr lang="en-US" smtClean="0"/>
-              <a:t>8/18/2026</a:t>
+              <a:t>8/20/2026</a:t>
             </a:fld>
             <a:endParaRPr lang="en-US"/>
           </a:p>
@@ -8229,7 +8229,7 @@
           <a:p>
             <a:fld id="{109E55A0-C911-4F03-82FC-7E5926047D46}" type="datetime1">
               <a:rPr lang="en-US" smtClean="0"/>
-              <a:t>8/18/2026</a:t>
+              <a:t>8/20/2026</a:t>
             </a:fld>
             <a:endParaRPr lang="en-US"/>
           </a:p>
@@ -8378,7 +8378,7 @@
           <a:p>
             <a:fld id="{2B7B7EE0-7771-4CD5-9B2B-3550753A54A1}" type="datetime1">
               <a:rPr lang="en-US" smtClean="0"/>
-              <a:t>8/18/2026</a:t>
+              <a:t>8/20/2026</a:t>
             </a:fld>
             <a:endParaRPr lang="en-US"/>
           </a:p>
@@ -8689,7 +8689,7 @@
           <a:p>
             <a:fld id="{F8B318B3-0E87-4416-A9B8-D891968C2727}" type="datetime1">
               <a:rPr lang="en-US" smtClean="0"/>
-              <a:t>8/18/2026</a:t>
+              <a:t>8/20/2026</a:t>
             </a:fld>
             <a:endParaRPr lang="en-US"/>
           </a:p>
@@ -8977,7 +8977,7 @@
           <a:p>
             <a:fld id="{EA476A42-A091-4468-A075-64A31BE59948}" type="datetime1">
               <a:rPr lang="en-US" smtClean="0"/>
-              <a:t>8/18/2026</a:t>
+              <a:t>8/20/2026</a:t>
             </a:fld>
             <a:endParaRPr lang="en-US"/>
           </a:p>
@@ -9218,7 +9218,7 @@
           <a:p>
             <a:fld id="{54D997E8-DDEE-43F1-8D9B-F8A1E11DE488}" type="datetime1">
               <a:rPr lang="en-US" smtClean="0"/>
-              <a:t>8/18/2026</a:t>
+              <a:t>8/20/2026</a:t>
             </a:fld>
             <a:endParaRPr lang="en-US"/>
           </a:p>
@@ -9797,12 +9797,20 @@
           <a:lstStyle/>
           <a:p>
             <a:r>
+              <a:rPr lang="en-US">
+                <a:solidFill>
+                  <a:srgbClr val="5C5962"/>
+                </a:solidFill>
+              </a:rPr>
+              <a:t>© 2026-27 </a:t>
+            </a:r>
+            <a:r>
               <a:rPr lang="en-US" dirty="0">
                 <a:solidFill>
                   <a:srgbClr val="5C5962"/>
                 </a:solidFill>
               </a:rPr>
-              <a:t>© 2026 Released under the </a:t>
+              <a:t>Released under the </a:t>
             </a:r>
             <a:r>
               <a:rPr lang="en-US" dirty="0">
@@ -15183,7 +15191,15 @@
             <a:pPr lvl="1"/>
             <a:r>
               <a:rPr lang="en-US" dirty="0"/>
-              <a:t>For excused absence, you will need to contact the instructor by email.</a:t>
+              <a:t>For excused absence, you will need to contact the instructor by email </a:t>
+            </a:r>
+            <a:r>
+              <a:rPr lang="en-US" i="1" dirty="0"/>
+              <a:t>preferably </a:t>
+            </a:r>
+            <a:r>
+              <a:rPr lang="en-US" dirty="0"/>
+              <a:t>in advance.</a:t>
             </a:r>
           </a:p>
         </p:txBody>
@@ -15314,15 +15330,7 @@
             </a:r>
             <a:r>
               <a:rPr lang="en-US" dirty="0"/>
-              <a:t> It is </a:t>
-            </a:r>
-            <a:r>
-              <a:rPr lang="en-US" dirty="0" err="1"/>
-              <a:t>devided</a:t>
-            </a:r>
-            <a:r>
-              <a:rPr lang="en-US" dirty="0"/>
-              <a:t> into 3 deliverable stages.  Together these count for </a:t>
+              <a:t> It is divided into 3 deliverable stages. Together these count for </a:t>
             </a:r>
             <a:r>
               <a:rPr lang="en-US" b="1" dirty="0"/>
@@ -15541,7 +15549,7 @@
         </p:spPr>
         <p:txBody>
           <a:bodyPr>
-            <a:normAutofit/>
+            <a:normAutofit fontScale="92500" lnSpcReduction="20000"/>
           </a:bodyPr>
           <a:lstStyle/>
           <a:p>
@@ -15596,6 +15604,16 @@
                 </a:solidFill>
               </a:rPr>
               <a:t>If you don’t complete individual projects, you might not be assigned to a project team</a:t>
+            </a:r>
+          </a:p>
+          <a:p>
+            <a:r>
+              <a:rPr lang="en-US" dirty="0">
+                <a:solidFill>
+                  <a:srgbClr val="FF0000"/>
+                </a:solidFill>
+              </a:rPr>
+              <a:t>If you don’t present your final project, you might not pass the class</a:t>
             </a:r>
           </a:p>
         </p:txBody>
@@ -17444,7 +17462,7 @@
             </a:r>
             <a:r>
               <a:rPr lang="en-US" b="1" dirty="0"/>
-              <a:t>5 days </a:t>
+              <a:t>7 days </a:t>
             </a:r>
             <a:r>
               <a:rPr lang="en-US" dirty="0"/>
@@ -22098,7 +22116,7 @@
           </a:ln>
           <a:extLst>
             <a:ext uri="{C572A759-6A51-4108-AA02-DFA0A04FC94B}">
-              <ma14:wrappingTextBoxFlag xmlns="" xmlns:m="http://schemas.openxmlformats.org/officeDocument/2006/math" xmlns:a14="http://schemas.microsoft.com/office/drawing/2010/main" xmlns:ma14="http://schemas.microsoft.com/office/mac/drawingml/2011/main" val="1"/>
+              <ma14:wrappingTextBoxFlag xmlns:ma14="http://schemas.microsoft.com/office/mac/drawingml/2011/main" xmlns:a14="http://schemas.microsoft.com/office/drawing/2010/main" xmlns:m="http://schemas.openxmlformats.org/officeDocument/2006/math" xmlns="" val="1"/>
             </a:ext>
           </a:extLst>
         </p:spPr>
@@ -22159,7 +22177,7 @@
           </a:ln>
           <a:extLst>
             <a:ext uri="{C572A759-6A51-4108-AA02-DFA0A04FC94B}">
-              <ma14:wrappingTextBoxFlag xmlns="" xmlns:m="http://schemas.openxmlformats.org/officeDocument/2006/math" xmlns:a14="http://schemas.microsoft.com/office/drawing/2010/main" xmlns:ma14="http://schemas.microsoft.com/office/mac/drawingml/2011/main" val="1"/>
+              <ma14:wrappingTextBoxFlag xmlns:ma14="http://schemas.microsoft.com/office/mac/drawingml/2011/main" xmlns:a14="http://schemas.microsoft.com/office/drawing/2010/main" xmlns:m="http://schemas.openxmlformats.org/officeDocument/2006/math" xmlns="" val="1"/>
             </a:ext>
           </a:extLst>
         </p:spPr>
@@ -22318,7 +22336,7 @@
           </a:ln>
           <a:extLst>
             <a:ext uri="{C572A759-6A51-4108-AA02-DFA0A04FC94B}">
-              <ma14:wrappingTextBoxFlag xmlns:ma14="http://schemas.microsoft.com/office/mac/drawingml/2011/main" xmlns:a14="http://schemas.microsoft.com/office/drawing/2010/main" xmlns:m="http://schemas.openxmlformats.org/officeDocument/2006/math" xmlns="" val="1"/>
+              <ma14:wrappingTextBoxFlag xmlns="" xmlns:m="http://schemas.openxmlformats.org/officeDocument/2006/math" xmlns:a14="http://schemas.microsoft.com/office/drawing/2010/main" xmlns:ma14="http://schemas.microsoft.com/office/mac/drawingml/2011/main" val="1"/>
             </a:ext>
           </a:extLst>
         </p:spPr>
@@ -22412,7 +22430,7 @@
           </a:ln>
           <a:extLst>
             <a:ext uri="{C572A759-6A51-4108-AA02-DFA0A04FC94B}">
-              <ma14:wrappingTextBoxFlag xmlns:ma14="http://schemas.microsoft.com/office/mac/drawingml/2011/main" xmlns:a14="http://schemas.microsoft.com/office/drawing/2010/main" xmlns:m="http://schemas.openxmlformats.org/officeDocument/2006/math" xmlns="" val="1"/>
+              <ma14:wrappingTextBoxFlag xmlns="" xmlns:m="http://schemas.openxmlformats.org/officeDocument/2006/math" xmlns:a14="http://schemas.microsoft.com/office/drawing/2010/main" xmlns:ma14="http://schemas.microsoft.com/office/mac/drawingml/2011/main" val="1"/>
             </a:ext>
           </a:extLst>
         </p:spPr>

</xml_diff>

<commit_message>
fixing small things, typos, etc
</commit_message>
<xml_diff>
--- a/Slides/Module 01.1 Course Introduction.pptx
+++ b/Slides/Module 01.1 Course Introduction.pptx
@@ -3196,7 +3196,7 @@
           <a:p>
             <a:fld id="{7C7E5181-6CF5-45F7-A87A-E0E0B1FD7549}" type="datetimeFigureOut">
               <a:rPr lang="en-US" smtClean="0"/>
-              <a:t>8/20/2026</a:t>
+              <a:t>9/11/2026</a:t>
             </a:fld>
             <a:endParaRPr lang="en-US"/>
           </a:p>
@@ -6055,7 +6055,7 @@
           <a:p>
             <a:fld id="{5D2A64DE-480B-420F-9649-4F8E696E08E0}" type="datetime1">
               <a:rPr lang="en-US" smtClean="0"/>
-              <a:t>8/20/2026</a:t>
+              <a:t>9/11/2026</a:t>
             </a:fld>
             <a:endParaRPr lang="en-US"/>
           </a:p>
@@ -6289,7 +6289,7 @@
           <a:p>
             <a:fld id="{0D3616D0-8311-4107-9726-6B805E7D05BA}" type="datetime1">
               <a:rPr lang="en-US" smtClean="0"/>
-              <a:t>8/20/2026</a:t>
+              <a:t>9/11/2026</a:t>
             </a:fld>
             <a:endParaRPr lang="en-US"/>
           </a:p>
@@ -6497,7 +6497,7 @@
           <a:p>
             <a:fld id="{3BC2557A-5C88-417A-A763-5AC779462A5F}" type="datetime1">
               <a:rPr lang="en-US" smtClean="0"/>
-              <a:t>8/20/2026</a:t>
+              <a:t>9/11/2026</a:t>
             </a:fld>
             <a:endParaRPr lang="en-US"/>
           </a:p>
@@ -7021,7 +7021,7 @@
           <a:p>
             <a:fld id="{07C7BFD4-467E-4EDE-93EA-052F5B39A4E5}" type="datetime1">
               <a:rPr lang="en-US" smtClean="0"/>
-              <a:t>8/20/2026</a:t>
+              <a:t>9/11/2026</a:t>
             </a:fld>
             <a:endParaRPr lang="en-US"/>
           </a:p>
@@ -7334,7 +7334,7 @@
           <a:p>
             <a:fld id="{A533CBE2-D5BE-47AC-ADC2-9CDFC1D0CF90}" type="datetime1">
               <a:rPr lang="en-US" smtClean="0"/>
-              <a:t>8/20/2026</a:t>
+              <a:t>9/11/2026</a:t>
             </a:fld>
             <a:endParaRPr lang="en-US"/>
           </a:p>
@@ -7635,7 +7635,7 @@
           <a:p>
             <a:fld id="{39B7EDB1-CE74-4951-85A2-0B01C2128E28}" type="datetime1">
               <a:rPr lang="en-US" smtClean="0"/>
-              <a:t>8/20/2026</a:t>
+              <a:t>9/11/2026</a:t>
             </a:fld>
             <a:endParaRPr lang="en-US"/>
           </a:p>
@@ -8083,7 +8083,7 @@
           <a:p>
             <a:fld id="{2BC7EB92-A5C2-4807-A9DC-9EDE6CBFB241}" type="datetime1">
               <a:rPr lang="en-US" smtClean="0"/>
-              <a:t>8/20/2026</a:t>
+              <a:t>9/11/2026</a:t>
             </a:fld>
             <a:endParaRPr lang="en-US"/>
           </a:p>
@@ -8229,7 +8229,7 @@
           <a:p>
             <a:fld id="{109E55A0-C911-4F03-82FC-7E5926047D46}" type="datetime1">
               <a:rPr lang="en-US" smtClean="0"/>
-              <a:t>8/20/2026</a:t>
+              <a:t>9/11/2026</a:t>
             </a:fld>
             <a:endParaRPr lang="en-US"/>
           </a:p>
@@ -8378,7 +8378,7 @@
           <a:p>
             <a:fld id="{2B7B7EE0-7771-4CD5-9B2B-3550753A54A1}" type="datetime1">
               <a:rPr lang="en-US" smtClean="0"/>
-              <a:t>8/20/2026</a:t>
+              <a:t>9/11/2026</a:t>
             </a:fld>
             <a:endParaRPr lang="en-US"/>
           </a:p>
@@ -8689,7 +8689,7 @@
           <a:p>
             <a:fld id="{F8B318B3-0E87-4416-A9B8-D891968C2727}" type="datetime1">
               <a:rPr lang="en-US" smtClean="0"/>
-              <a:t>8/20/2026</a:t>
+              <a:t>9/11/2026</a:t>
             </a:fld>
             <a:endParaRPr lang="en-US"/>
           </a:p>
@@ -8977,7 +8977,7 @@
           <a:p>
             <a:fld id="{EA476A42-A091-4468-A075-64A31BE59948}" type="datetime1">
               <a:rPr lang="en-US" smtClean="0"/>
-              <a:t>8/20/2026</a:t>
+              <a:t>9/11/2026</a:t>
             </a:fld>
             <a:endParaRPr lang="en-US"/>
           </a:p>
@@ -9218,7 +9218,7 @@
           <a:p>
             <a:fld id="{54D997E8-DDEE-43F1-8D9B-F8A1E11DE488}" type="datetime1">
               <a:rPr lang="en-US" smtClean="0"/>
-              <a:t>8/20/2026</a:t>
+              <a:t>9/11/2026</a:t>
             </a:fld>
             <a:endParaRPr lang="en-US"/>
           </a:p>
@@ -15729,7 +15729,9 @@
         </p:nvSpPr>
         <p:spPr/>
         <p:txBody>
-          <a:bodyPr/>
+          <a:bodyPr>
+            <a:normAutofit/>
+          </a:bodyPr>
           <a:lstStyle/>
           <a:p>
             <a:r>
@@ -15767,6 +15769,21 @@
             <a:r>
               <a:rPr lang="en-US" dirty="0"/>
               <a:t>React for webapps</a:t>
+            </a:r>
+          </a:p>
+          <a:p>
+            <a:pPr lvl="1"/>
+            <a:r>
+              <a:rPr lang="en-US" dirty="0"/>
+              <a:t>Playwright </a:t>
+            </a:r>
+            <a:r>
+              <a:rPr lang="en-US"/>
+              <a:t>for End-to-End </a:t>
+            </a:r>
+            <a:r>
+              <a:rPr lang="en-US" dirty="0"/>
+              <a:t>Testing</a:t>
             </a:r>
           </a:p>
           <a:p>
@@ -22116,7 +22133,7 @@
           </a:ln>
           <a:extLst>
             <a:ext uri="{C572A759-6A51-4108-AA02-DFA0A04FC94B}">
-              <ma14:wrappingTextBoxFlag xmlns:ma14="http://schemas.microsoft.com/office/mac/drawingml/2011/main" xmlns:a14="http://schemas.microsoft.com/office/drawing/2010/main" xmlns:m="http://schemas.openxmlformats.org/officeDocument/2006/math" xmlns="" val="1"/>
+              <ma14:wrappingTextBoxFlag xmlns="" xmlns:m="http://schemas.openxmlformats.org/officeDocument/2006/math" xmlns:a14="http://schemas.microsoft.com/office/drawing/2010/main" xmlns:ma14="http://schemas.microsoft.com/office/mac/drawingml/2011/main" val="1"/>
             </a:ext>
           </a:extLst>
         </p:spPr>
@@ -22177,7 +22194,7 @@
           </a:ln>
           <a:extLst>
             <a:ext uri="{C572A759-6A51-4108-AA02-DFA0A04FC94B}">
-              <ma14:wrappingTextBoxFlag xmlns:ma14="http://schemas.microsoft.com/office/mac/drawingml/2011/main" xmlns:a14="http://schemas.microsoft.com/office/drawing/2010/main" xmlns:m="http://schemas.openxmlformats.org/officeDocument/2006/math" xmlns="" val="1"/>
+              <ma14:wrappingTextBoxFlag xmlns="" xmlns:m="http://schemas.openxmlformats.org/officeDocument/2006/math" xmlns:a14="http://schemas.microsoft.com/office/drawing/2010/main" xmlns:ma14="http://schemas.microsoft.com/office/mac/drawingml/2011/main" val="1"/>
             </a:ext>
           </a:extLst>
         </p:spPr>
@@ -22336,7 +22353,7 @@
           </a:ln>
           <a:extLst>
             <a:ext uri="{C572A759-6A51-4108-AA02-DFA0A04FC94B}">
-              <ma14:wrappingTextBoxFlag xmlns="" xmlns:m="http://schemas.openxmlformats.org/officeDocument/2006/math" xmlns:a14="http://schemas.microsoft.com/office/drawing/2010/main" xmlns:ma14="http://schemas.microsoft.com/office/mac/drawingml/2011/main" val="1"/>
+              <ma14:wrappingTextBoxFlag xmlns:ma14="http://schemas.microsoft.com/office/mac/drawingml/2011/main" xmlns:a14="http://schemas.microsoft.com/office/drawing/2010/main" xmlns:m="http://schemas.openxmlformats.org/officeDocument/2006/math" xmlns="" val="1"/>
             </a:ext>
           </a:extLst>
         </p:spPr>
@@ -22430,7 +22447,7 @@
           </a:ln>
           <a:extLst>
             <a:ext uri="{C572A759-6A51-4108-AA02-DFA0A04FC94B}">
-              <ma14:wrappingTextBoxFlag xmlns="" xmlns:m="http://schemas.openxmlformats.org/officeDocument/2006/math" xmlns:a14="http://schemas.microsoft.com/office/drawing/2010/main" xmlns:ma14="http://schemas.microsoft.com/office/mac/drawingml/2011/main" val="1"/>
+              <ma14:wrappingTextBoxFlag xmlns:ma14="http://schemas.microsoft.com/office/mac/drawingml/2011/main" xmlns:a14="http://schemas.microsoft.com/office/drawing/2010/main" xmlns:m="http://schemas.openxmlformats.org/officeDocument/2006/math" xmlns="" val="1"/>
             </a:ext>
           </a:extLst>
         </p:spPr>

</xml_diff>